<commit_message>
﻿Match the deck to the new feedback form
The troubleshooting slide still described the old GitHub issue link and told
readers not to include personal details - which now contradicts the app, since
the form asks for a name and email. It now describes the two questions and
explains that contact details stay private.

Also tightened the privacy answer on the quick-reference slide. "Nothing leaves
your browser" was written when the page had no way to send anything; with a
feedback form it is imprecise. It now says pay details never leave the browser
and that the form is separate and optional - accurate, and still the reassurance
families actually need.
</commit_message>
<xml_diff>
--- a/Military-Pay-Estimator-Guide.pptx
+++ b/Military-Pay-Estimator-Guide.pptx
@@ -5103,7 +5103,7 @@
                 <a:ea typeface="Calibri" pitchFamily="34" charset="-122"/>
                 <a:cs typeface="Calibri" pitchFamily="34" charset="-120"/>
               </a:rPr>
-              <a:t>There is a "Report an issue" link at the bottom of the page. It opens a short form asking for your rank, duty station, home state, what the tool showed, and what your LES shows.</a:t>
+              <a:t>Use the "Share your feedback" button at the bottom of the page. It asks two questions — whether the estimate matched your actual pay, and what would make it better — plus your name and email so we can follow up.</a:t>
             </a:r>
             <a:endParaRPr lang="en-US" sz="1300" dirty="0"/>
           </a:p>
@@ -5142,7 +5142,7 @@
                 <a:ea typeface="Calibri" pitchFamily="34" charset="-122"/>
                 <a:cs typeface="Calibri" pitchFamily="34" charset="-120"/>
               </a:rPr>
-              <a:t>Please do not include personal or identifying details.</a:t>
+              <a:t>Your name and email are never shown publicly. Please do not include account numbers or other sensitive details.</a:t>
             </a:r>
             <a:endParaRPr lang="en-US" sz="1200" dirty="0"/>
           </a:p>
@@ -6474,7 +6474,7 @@
                 <a:ea typeface="Calibri" pitchFamily="34" charset="-122"/>
                 <a:cs typeface="Calibri" pitchFamily="34" charset="-120"/>
               </a:rPr>
-              <a:t>No. Nothing leaves your browser.</a:t>
+              <a:t>No. Your pay details never leave your browser. The feedback form is separate and optional.</a:t>
             </a:r>
             <a:endParaRPr lang="en-US" sz="1250" dirty="0"/>
           </a:p>
@@ -6894,7 +6894,7 @@
                 <a:ea typeface="Calibri" pitchFamily="34" charset="-122"/>
                 <a:cs typeface="Calibri" pitchFamily="34" charset="-120"/>
               </a:rPr>
-              <a:t>"Report an issue" link at the bottom of the page.</a:t>
+              <a:t>"Share your feedback" button at the bottom of the page.</a:t>
             </a:r>
             <a:endParaRPr lang="en-US" sz="1250" dirty="0"/>
           </a:p>

</xml_diff>